<commit_message>
EVM1110E Buổi 11: deck 32 slide (Alexandria + Roboto) theo Luật Báo chí 2025 và Luật QC 2025 nguyên văn; Buổi 10 cập nhật quyết định GV
Co-Authored-By: Claude Opus 5.5 <noreply@anthropic.com>
Claude-Session: https://claude.ai/code/session_014QwQ68qeN46CsLnynfoTqG
</commit_message>
<xml_diff>
--- a/courses/EVM1110E/slides/W10_slides.pptx
+++ b/courses/EVM1110E/slides/W10_slides.pptx
@@ -2180,7 +2180,7 @@
             <a:r>
               <a:rPr lang="en-US" dirty="0"/>
               <a:t>Nói: Cần bao nhiêu mét vuông? Quy tắc: sức chứa xấp xỉ diện tích dùng được chia diện tích mỗi người theo kiểu bố trí. Nhưng các quy tắc vênh nhau rất nhiều. Theo blog Social Tables, bàn tròn tiệc khoảng 1,0 đến 1,1 mét vuông mỗi khách. Theo Price, 2004, được giáo trình Dowson dẫn: cabaret hoặc bàn tiệc 4 mét vuông mỗi khách. Với 600 khách: khoảng 610–670 mét vuông chỉ cho khu bàn — hay khoảng 2.400 mét vuông? Chênh nhau gần bốn lần. Bài học: không tin một con số. Xin bảng sức chứa và sơ đồ chính thức của địa điểm, hỏi “diện tích này là gì”, và đo khi site check. Ví dụ: cùng một trung tâm hội nghị ở TP.HCM, các trang ghi từ hơn 4.000 đến khoảng 10.000 mét vuông.
-(GV: Tính trên bảng cùng lớp (giáo án). Phiếu Thực hành 1 dùng 860–920 m² theo V08 (610–670 m² khu bàn + ~250 m² sân khấu, lối đi, buffet, nhà tài trợ). Chưa xác định Price (2004) và Social Tables có dùng cùng định nghĩa “diện tích mỗi người” không — [NEEDS PROFESSOR INPUT: giữ số V08 cho phiếu, hay đổi theo giáo trình]. Không nêu tên địa điểm thật (quyết định GV 4). Sức chứa chính thức theo giấy phép → môn Quản trị rủi ro.)
+(GV: Tính trên bảng cùng lớp (giáo án). Phiếu Thực hành 1 dùng 860–920 m² theo V08 (610–670 m² khu bàn + ~250 m² sân khấu, lối đi, buffet, nhà tài trợ). Quyết định GV (4/10/2026): giữ số V08 cho phiếu — ở Việt Nam không nhiều mặt bằng đáp ứng được mức của Dowson/Price. Có thể nói với lớp: mức 4 m²/khách là chuẩn rộng rãi trong giáo trình Anh; thực tế khách sạn Việt Nam thường bố trí dày hơn, nên càng phải kiểm tra tầm nhìn và lối đi khi site check. Không nêu tên địa điểm thật (quyết định GV 4). Sức chứa chính thức theo giấy phép → môn Quản trị rủi ro.)
 Hỏi lớp: “Ballroom 1.200 m² có chắc chứa thoải mái 600 khách?”
 Chuyển ý: Sơ đồ mặt bằng làm thế nào?</a:t>
             </a:r>
@@ -3635,7 +3635,7 @@
             <a:r>
               <a:rPr lang="en-US" dirty="0"/>
               <a:t>Nói: Tài liệu tham khảo của Buổi 10, theo APA 7. Chương 5 và 9 của Dowson và cộng sự là phần đọc thêm.
-(GV: Trang hiệp hội, khảo sát và báo chí (V01, V03, V06–V08, V10–V12): danh mục APA đầy đủ trong buoi-10_tu-lieu-tong-hop.md, mục 6 và 8. [VERIFY: phụ đề sách Dowson theo trang bìa.])
+(GV: Trang hiệp hội, khảo sát và báo chí (V01, V03, V06–V08, V10–V12): danh mục APA đầy đủ trong buoi-10_tu-lieu-tong-hop.md, mục 6 và 8.)
 Hỏi lớp: —
 Chuyển ý: —</a:t>
             </a:r>
@@ -27687,7 +27687,7 @@
                 <a:ea typeface="Alexandria" pitchFamily="34" charset="-122"/>
                 <a:cs typeface="Alexandria" pitchFamily="34" charset="-120"/>
               </a:rPr>
-              <a:t>Event planning and management: Principles, planning and practice</a:t>
+              <a:t>Event planning and management: Principle, planning and practice</a:t>
             </a:r>
             <a:pPr indent="0" marL="0">
               <a:spcAft>

</xml_diff>